<commit_message>
Judge-facing artifacts: truthful numbers in metadata YAML and decks
- submission_metadata.yaml: fix the false 'auto-pins PYTHONHASHSEED' note in
  reproduce_command; runtime/memory now the Docker-measured worst case
  (193s, ~6.1GB container peak); AI-tools disclosure extended.
- build_deck.py source corrected (~80-180s, ~104s claims); generated deck
  rebuilt; POLISHED deck patched in place (184s->193s x2, 4.33GB->~6.1GB)
  and its PDF regenerated via PowerPoint.
- scripts/patch_deck_numbers.py kept for future number rolls.
</commit_message>
<xml_diff>
--- a/docs/HireFit_Ranker_Redrob_POLISHED.pptx
+++ b/docs/HireFit_Ranker_Redrob_POLISHED.pptx
@@ -1476,6 +1476,10 @@
           </a:solidFill>
           <a:ln/>
         </p:spPr>
+        <p:txBody>
+          <a:bodyPr/>
+          <a:p/>
+        </p:txBody>
       </p:sp>
       <p:sp>
         <p:nvSpPr>
@@ -1498,6 +1502,10 @@
           </a:solidFill>
           <a:ln/>
         </p:spPr>
+        <p:txBody>
+          <a:bodyPr/>
+          <a:p/>
+        </p:txBody>
       </p:sp>
       <p:sp>
         <p:nvSpPr>
@@ -1529,6 +1537,10 @@
             <a:prstDash val="solid"/>
           </a:ln>
         </p:spPr>
+        <p:txBody>
+          <a:bodyPr/>
+          <a:p/>
+        </p:txBody>
       </p:sp>
       <p:pic>
         <p:nvPicPr>
@@ -1810,6 +1822,10 @@
             </a:outerShdw>
           </a:effectLst>
         </p:spPr>
+        <p:txBody>
+          <a:bodyPr/>
+          <a:p/>
+        </p:txBody>
       </p:sp>
       <p:sp>
         <p:nvSpPr>
@@ -1922,6 +1938,10 @@
             </a:outerShdw>
           </a:effectLst>
         </p:spPr>
+        <p:txBody>
+          <a:bodyPr/>
+          <a:p/>
+        </p:txBody>
       </p:sp>
       <p:sp>
         <p:nvSpPr>
@@ -1956,7 +1976,7 @@
                 <a:ea typeface="Arial" pitchFamily="34" charset="-122"/>
                 <a:cs typeface="Arial" pitchFamily="34" charset="-120"/>
               </a:rPr>
-              <a:t>184s</a:t>
+              <a:t>193s</a:t>
             </a:r>
             <a:endParaRPr lang="en-US" sz="3300" dirty="0"/>
           </a:p>
@@ -2034,6 +2054,10 @@
             </a:outerShdw>
           </a:effectLst>
         </p:spPr>
+        <p:txBody>
+          <a:bodyPr/>
+          <a:p/>
+        </p:txBody>
       </p:sp>
       <p:sp>
         <p:nvSpPr>
@@ -2146,6 +2170,10 @@
             </a:outerShdw>
           </a:effectLst>
         </p:spPr>
+        <p:txBody>
+          <a:bodyPr/>
+          <a:p/>
+        </p:txBody>
       </p:sp>
       <p:sp>
         <p:nvSpPr>
@@ -2489,6 +2517,10 @@
             </a:outerShdw>
           </a:effectLst>
         </p:spPr>
+        <p:txBody>
+          <a:bodyPr/>
+          <a:p/>
+        </p:txBody>
       </p:sp>
       <p:pic>
         <p:nvPicPr>
@@ -2703,6 +2735,10 @@
             </a:outerShdw>
           </a:effectLst>
         </p:spPr>
+        <p:txBody>
+          <a:bodyPr/>
+          <a:p/>
+        </p:txBody>
       </p:sp>
       <p:sp>
         <p:nvSpPr>
@@ -2878,6 +2914,10 @@
             </a:outerShdw>
           </a:effectLst>
         </p:spPr>
+        <p:txBody>
+          <a:bodyPr/>
+          <a:p/>
+        </p:txBody>
       </p:sp>
       <p:sp>
         <p:nvSpPr>
@@ -2990,7 +3030,7 @@
                 <a:ea typeface="Arial" pitchFamily="34" charset="-122"/>
                 <a:cs typeface="Arial" pitchFamily="34" charset="-120"/>
               </a:rPr>
-              <a:t>4.33 GB peak</a:t>
+              <a:t>~6.1 GB peak</a:t>
             </a:r>
             <a:endParaRPr lang="en-US" sz="1250" dirty="0"/>
           </a:p>
@@ -3053,6 +3093,10 @@
             </a:outerShdw>
           </a:effectLst>
         </p:spPr>
+        <p:txBody>
+          <a:bodyPr/>
+          <a:p/>
+        </p:txBody>
       </p:sp>
       <p:sp>
         <p:nvSpPr>
@@ -3228,6 +3272,10 @@
             </a:outerShdw>
           </a:effectLst>
         </p:spPr>
+        <p:txBody>
+          <a:bodyPr/>
+          <a:p/>
+        </p:txBody>
       </p:sp>
       <p:sp>
         <p:nvSpPr>
@@ -3403,6 +3451,10 @@
             </a:outerShdw>
           </a:effectLst>
         </p:spPr>
+        <p:txBody>
+          <a:bodyPr/>
+          <a:p/>
+        </p:txBody>
       </p:sp>
       <p:sp>
         <p:nvSpPr>
@@ -3434,6 +3486,10 @@
             <a:prstDash val="solid"/>
           </a:ln>
         </p:spPr>
+        <p:txBody>
+          <a:bodyPr/>
+          <a:p/>
+        </p:txBody>
       </p:sp>
       <p:pic>
         <p:nvPicPr>
@@ -3945,6 +4001,10 @@
           </a:solidFill>
           <a:ln/>
         </p:spPr>
+        <p:txBody>
+          <a:bodyPr/>
+          <a:p/>
+        </p:txBody>
       </p:sp>
       <p:sp>
         <p:nvSpPr>
@@ -3967,6 +4027,10 @@
           </a:solidFill>
           <a:ln/>
         </p:spPr>
+        <p:txBody>
+          <a:bodyPr/>
+          <a:p/>
+        </p:txBody>
       </p:sp>
       <p:sp>
         <p:nvSpPr>
@@ -4105,6 +4169,10 @@
             </a:outerShdw>
           </a:effectLst>
         </p:spPr>
+        <p:txBody>
+          <a:bodyPr/>
+          <a:p/>
+        </p:txBody>
       </p:sp>
       <p:pic>
         <p:nvPicPr>
@@ -4202,6 +4270,10 @@
             </a:outerShdw>
           </a:effectLst>
         </p:spPr>
+        <p:txBody>
+          <a:bodyPr/>
+          <a:p/>
+        </p:txBody>
       </p:sp>
       <p:pic>
         <p:nvPicPr>
@@ -4299,6 +4371,10 @@
             </a:outerShdw>
           </a:effectLst>
         </p:spPr>
+        <p:txBody>
+          <a:bodyPr/>
+          <a:p/>
+        </p:txBody>
       </p:sp>
       <p:pic>
         <p:nvPicPr>
@@ -4396,6 +4472,10 @@
             </a:outerShdw>
           </a:effectLst>
         </p:spPr>
+        <p:txBody>
+          <a:bodyPr/>
+          <a:p/>
+        </p:txBody>
       </p:sp>
       <p:pic>
         <p:nvPicPr>
@@ -4454,7 +4534,7 @@
                 <a:ea typeface="Arial" pitchFamily="34" charset="-122"/>
                 <a:cs typeface="Arial" pitchFamily="34" charset="-120"/>
               </a:rPr>
-              <a:t>100K scored offline, on CPU, in 184s</a:t>
+              <a:t>100K scored offline, on CPU, in 193s</a:t>
             </a:r>
             <a:endParaRPr lang="en-US" sz="1250" dirty="0"/>
           </a:p>
@@ -4493,6 +4573,10 @@
             </a:outerShdw>
           </a:effectLst>
         </p:spPr>
+        <p:txBody>
+          <a:bodyPr/>
+          <a:p/>
+        </p:txBody>
       </p:sp>
       <p:pic>
         <p:nvPicPr>
@@ -4823,6 +4907,10 @@
             </a:outerShdw>
           </a:effectLst>
         </p:spPr>
+        <p:txBody>
+          <a:bodyPr/>
+          <a:p/>
+        </p:txBody>
       </p:sp>
       <p:sp>
         <p:nvSpPr>
@@ -4854,6 +4942,10 @@
             <a:prstDash val="solid"/>
           </a:ln>
         </p:spPr>
+        <p:txBody>
+          <a:bodyPr/>
+          <a:p/>
+        </p:txBody>
       </p:sp>
       <p:pic>
         <p:nvPicPr>
@@ -4993,6 +5085,10 @@
             </a:outerShdw>
           </a:effectLst>
         </p:spPr>
+        <p:txBody>
+          <a:bodyPr/>
+          <a:p/>
+        </p:txBody>
       </p:sp>
       <p:sp>
         <p:nvSpPr>
@@ -5024,6 +5120,10 @@
             <a:prstDash val="solid"/>
           </a:ln>
         </p:spPr>
+        <p:txBody>
+          <a:bodyPr/>
+          <a:p/>
+        </p:txBody>
       </p:sp>
       <p:pic>
         <p:nvPicPr>
@@ -5163,6 +5263,10 @@
             </a:outerShdw>
           </a:effectLst>
         </p:spPr>
+        <p:txBody>
+          <a:bodyPr/>
+          <a:p/>
+        </p:txBody>
       </p:sp>
       <p:sp>
         <p:nvSpPr>
@@ -5194,6 +5298,10 @@
             <a:prstDash val="solid"/>
           </a:ln>
         </p:spPr>
+        <p:txBody>
+          <a:bodyPr/>
+          <a:p/>
+        </p:txBody>
       </p:sp>
       <p:pic>
         <p:nvPicPr>
@@ -5333,6 +5441,10 @@
             </a:outerShdw>
           </a:effectLst>
         </p:spPr>
+        <p:txBody>
+          <a:bodyPr/>
+          <a:p/>
+        </p:txBody>
       </p:sp>
       <p:sp>
         <p:nvSpPr>
@@ -5364,6 +5476,10 @@
             <a:prstDash val="solid"/>
           </a:ln>
         </p:spPr>
+        <p:txBody>
+          <a:bodyPr/>
+          <a:p/>
+        </p:txBody>
       </p:sp>
       <p:pic>
         <p:nvPicPr>
@@ -5503,6 +5619,10 @@
             </a:outerShdw>
           </a:effectLst>
         </p:spPr>
+        <p:txBody>
+          <a:bodyPr/>
+          <a:p/>
+        </p:txBody>
       </p:sp>
       <p:sp>
         <p:nvSpPr>
@@ -5534,6 +5654,10 @@
             <a:prstDash val="solid"/>
           </a:ln>
         </p:spPr>
+        <p:txBody>
+          <a:bodyPr/>
+          <a:p/>
+        </p:txBody>
       </p:sp>
       <p:pic>
         <p:nvPicPr>
@@ -5920,6 +6044,10 @@
             </a:outerShdw>
           </a:effectLst>
         </p:spPr>
+        <p:txBody>
+          <a:bodyPr/>
+          <a:p/>
+        </p:txBody>
       </p:sp>
       <p:sp>
         <p:nvSpPr>
@@ -5951,6 +6079,10 @@
             <a:prstDash val="solid"/>
           </a:ln>
         </p:spPr>
+        <p:txBody>
+          <a:bodyPr/>
+          <a:p/>
+        </p:txBody>
       </p:sp>
       <p:pic>
         <p:nvPicPr>
@@ -6087,6 +6219,10 @@
             <a:prstDash val="solid"/>
           </a:ln>
         </p:spPr>
+        <p:txBody>
+          <a:bodyPr/>
+          <a:p/>
+        </p:txBody>
       </p:sp>
       <p:sp>
         <p:nvSpPr>
@@ -6157,6 +6293,10 @@
             <a:prstDash val="solid"/>
           </a:ln>
         </p:spPr>
+        <p:txBody>
+          <a:bodyPr/>
+          <a:p/>
+        </p:txBody>
       </p:sp>
       <p:sp>
         <p:nvSpPr>
@@ -6227,6 +6367,10 @@
             <a:prstDash val="solid"/>
           </a:ln>
         </p:spPr>
+        <p:txBody>
+          <a:bodyPr/>
+          <a:p/>
+        </p:txBody>
       </p:sp>
       <p:sp>
         <p:nvSpPr>
@@ -6297,6 +6441,10 @@
             <a:prstDash val="solid"/>
           </a:ln>
         </p:spPr>
+        <p:txBody>
+          <a:bodyPr/>
+          <a:p/>
+        </p:txBody>
       </p:sp>
       <p:sp>
         <p:nvSpPr>
@@ -6367,6 +6515,10 @@
             <a:prstDash val="solid"/>
           </a:ln>
         </p:spPr>
+        <p:txBody>
+          <a:bodyPr/>
+          <a:p/>
+        </p:txBody>
       </p:sp>
       <p:sp>
         <p:nvSpPr>
@@ -6440,6 +6592,10 @@
             </a:outerShdw>
           </a:effectLst>
         </p:spPr>
+        <p:txBody>
+          <a:bodyPr/>
+          <a:p/>
+        </p:txBody>
       </p:sp>
       <p:sp>
         <p:nvSpPr>
@@ -6527,6 +6683,10 @@
             </a:outerShdw>
           </a:effectLst>
         </p:spPr>
+        <p:txBody>
+          <a:bodyPr/>
+          <a:p/>
+        </p:txBody>
       </p:sp>
       <p:sp>
         <p:nvSpPr>
@@ -6558,6 +6718,10 @@
             <a:prstDash val="solid"/>
           </a:ln>
         </p:spPr>
+        <p:txBody>
+          <a:bodyPr/>
+          <a:p/>
+        </p:txBody>
       </p:sp>
       <p:pic>
         <p:nvPicPr>
@@ -7183,6 +7347,10 @@
             </a:outerShdw>
           </a:effectLst>
         </p:spPr>
+        <p:txBody>
+          <a:bodyPr/>
+          <a:p/>
+        </p:txBody>
       </p:sp>
       <p:sp>
         <p:nvSpPr>
@@ -7212,6 +7380,10 @@
             <a:prstDash val="solid"/>
           </a:ln>
         </p:spPr>
+        <p:txBody>
+          <a:bodyPr/>
+          <a:p/>
+        </p:txBody>
       </p:sp>
       <p:sp>
         <p:nvSpPr>
@@ -7410,6 +7582,10 @@
             </a:outerShdw>
           </a:effectLst>
         </p:spPr>
+        <p:txBody>
+          <a:bodyPr/>
+          <a:p/>
+        </p:txBody>
       </p:sp>
       <p:sp>
         <p:nvSpPr>
@@ -7439,6 +7615,10 @@
             <a:prstDash val="solid"/>
           </a:ln>
         </p:spPr>
+        <p:txBody>
+          <a:bodyPr/>
+          <a:p/>
+        </p:txBody>
       </p:sp>
       <p:sp>
         <p:nvSpPr>
@@ -7637,6 +7817,10 @@
             </a:outerShdw>
           </a:effectLst>
         </p:spPr>
+        <p:txBody>
+          <a:bodyPr/>
+          <a:p/>
+        </p:txBody>
       </p:sp>
       <p:sp>
         <p:nvSpPr>
@@ -7666,6 +7850,10 @@
             <a:prstDash val="solid"/>
           </a:ln>
         </p:spPr>
+        <p:txBody>
+          <a:bodyPr/>
+          <a:p/>
+        </p:txBody>
       </p:sp>
       <p:sp>
         <p:nvSpPr>
@@ -7864,6 +8052,10 @@
             </a:outerShdw>
           </a:effectLst>
         </p:spPr>
+        <p:txBody>
+          <a:bodyPr/>
+          <a:p/>
+        </p:txBody>
       </p:sp>
       <p:sp>
         <p:nvSpPr>
@@ -7893,6 +8085,10 @@
             <a:prstDash val="solid"/>
           </a:ln>
         </p:spPr>
+        <p:txBody>
+          <a:bodyPr/>
+          <a:p/>
+        </p:txBody>
       </p:sp>
       <p:sp>
         <p:nvSpPr>
@@ -8091,6 +8287,10 @@
             </a:outerShdw>
           </a:effectLst>
         </p:spPr>
+        <p:txBody>
+          <a:bodyPr/>
+          <a:p/>
+        </p:txBody>
       </p:sp>
       <p:sp>
         <p:nvSpPr>
@@ -8120,6 +8320,10 @@
             <a:prstDash val="solid"/>
           </a:ln>
         </p:spPr>
+        <p:txBody>
+          <a:bodyPr/>
+          <a:p/>
+        </p:txBody>
       </p:sp>
       <p:sp>
         <p:nvSpPr>
@@ -8318,6 +8522,10 @@
             </a:outerShdw>
           </a:effectLst>
         </p:spPr>
+        <p:txBody>
+          <a:bodyPr/>
+          <a:p/>
+        </p:txBody>
       </p:sp>
       <p:sp>
         <p:nvSpPr>
@@ -8347,6 +8555,10 @@
             <a:prstDash val="solid"/>
           </a:ln>
         </p:spPr>
+        <p:txBody>
+          <a:bodyPr/>
+          <a:p/>
+        </p:txBody>
       </p:sp>
       <p:sp>
         <p:nvSpPr>
@@ -8521,6 +8733,10 @@
             </a:outerShdw>
           </a:effectLst>
         </p:spPr>
+        <p:txBody>
+          <a:bodyPr/>
+          <a:p/>
+        </p:txBody>
       </p:sp>
       <p:sp>
         <p:nvSpPr>
@@ -8744,6 +8960,10 @@
             <a:prstDash val="solid"/>
           </a:ln>
         </p:spPr>
+        <p:txBody>
+          <a:bodyPr/>
+          <a:p/>
+        </p:txBody>
       </p:sp>
       <p:sp>
         <p:nvSpPr>
@@ -8823,6 +9043,10 @@
             <a:prstDash val="solid"/>
           </a:ln>
         </p:spPr>
+        <p:txBody>
+          <a:bodyPr/>
+          <a:p/>
+        </p:txBody>
       </p:sp>
       <p:sp>
         <p:nvSpPr>
@@ -8902,6 +9126,10 @@
             <a:prstDash val="solid"/>
           </a:ln>
         </p:spPr>
+        <p:txBody>
+          <a:bodyPr/>
+          <a:p/>
+        </p:txBody>
       </p:sp>
       <p:sp>
         <p:nvSpPr>
@@ -8981,6 +9209,10 @@
             <a:prstDash val="solid"/>
           </a:ln>
         </p:spPr>
+        <p:txBody>
+          <a:bodyPr/>
+          <a:p/>
+        </p:txBody>
       </p:sp>
       <p:sp>
         <p:nvSpPr>
@@ -9060,6 +9292,10 @@
             <a:prstDash val="solid"/>
           </a:ln>
         </p:spPr>
+        <p:txBody>
+          <a:bodyPr/>
+          <a:p/>
+        </p:txBody>
       </p:sp>
       <p:sp>
         <p:nvSpPr>
@@ -9375,6 +9611,10 @@
             </a:outerShdw>
           </a:effectLst>
         </p:spPr>
+        <p:txBody>
+          <a:bodyPr/>
+          <a:p/>
+        </p:txBody>
       </p:sp>
       <p:sp>
         <p:nvSpPr>
@@ -9406,6 +9646,10 @@
             <a:prstDash val="solid"/>
           </a:ln>
         </p:spPr>
+        <p:txBody>
+          <a:bodyPr/>
+          <a:p/>
+        </p:txBody>
       </p:sp>
       <p:pic>
         <p:nvPicPr>
@@ -9498,6 +9742,10 @@
             <a:prstDash val="solid"/>
           </a:ln>
         </p:spPr>
+        <p:txBody>
+          <a:bodyPr/>
+          <a:p/>
+        </p:txBody>
       </p:sp>
       <p:sp>
         <p:nvSpPr>
@@ -9613,6 +9861,10 @@
             </a:outerShdw>
           </a:effectLst>
         </p:spPr>
+        <p:txBody>
+          <a:bodyPr/>
+          <a:p/>
+        </p:txBody>
       </p:sp>
       <p:sp>
         <p:nvSpPr>
@@ -9644,6 +9896,10 @@
             <a:prstDash val="solid"/>
           </a:ln>
         </p:spPr>
+        <p:txBody>
+          <a:bodyPr/>
+          <a:p/>
+        </p:txBody>
       </p:sp>
       <p:pic>
         <p:nvPicPr>
@@ -9736,6 +9992,10 @@
             <a:prstDash val="solid"/>
           </a:ln>
         </p:spPr>
+        <p:txBody>
+          <a:bodyPr/>
+          <a:p/>
+        </p:txBody>
       </p:sp>
       <p:sp>
         <p:nvSpPr>
@@ -9851,6 +10111,10 @@
             </a:outerShdw>
           </a:effectLst>
         </p:spPr>
+        <p:txBody>
+          <a:bodyPr/>
+          <a:p/>
+        </p:txBody>
       </p:sp>
       <p:sp>
         <p:nvSpPr>
@@ -9882,6 +10146,10 @@
             <a:prstDash val="solid"/>
           </a:ln>
         </p:spPr>
+        <p:txBody>
+          <a:bodyPr/>
+          <a:p/>
+        </p:txBody>
       </p:sp>
       <p:pic>
         <p:nvPicPr>
@@ -9974,6 +10242,10 @@
             <a:prstDash val="solid"/>
           </a:ln>
         </p:spPr>
+        <p:txBody>
+          <a:bodyPr/>
+          <a:p/>
+        </p:txBody>
       </p:sp>
       <p:sp>
         <p:nvSpPr>
@@ -10089,6 +10361,10 @@
             </a:outerShdw>
           </a:effectLst>
         </p:spPr>
+        <p:txBody>
+          <a:bodyPr/>
+          <a:p/>
+        </p:txBody>
       </p:sp>
       <p:sp>
         <p:nvSpPr>
@@ -10120,6 +10396,10 @@
             <a:prstDash val="solid"/>
           </a:ln>
         </p:spPr>
+        <p:txBody>
+          <a:bodyPr/>
+          <a:p/>
+        </p:txBody>
       </p:sp>
       <p:pic>
         <p:nvPicPr>
@@ -10212,6 +10492,10 @@
             <a:prstDash val="solid"/>
           </a:ln>
         </p:spPr>
+        <p:txBody>
+          <a:bodyPr/>
+          <a:p/>
+        </p:txBody>
       </p:sp>
       <p:sp>
         <p:nvSpPr>
@@ -10327,6 +10611,10 @@
             </a:outerShdw>
           </a:effectLst>
         </p:spPr>
+        <p:txBody>
+          <a:bodyPr/>
+          <a:p/>
+        </p:txBody>
       </p:sp>
       <p:sp>
         <p:nvSpPr>
@@ -10358,6 +10646,10 @@
             <a:prstDash val="solid"/>
           </a:ln>
         </p:spPr>
+        <p:txBody>
+          <a:bodyPr/>
+          <a:p/>
+        </p:txBody>
       </p:sp>
       <p:pic>
         <p:nvPicPr>
@@ -10450,6 +10742,10 @@
             <a:prstDash val="solid"/>
           </a:ln>
         </p:spPr>
+        <p:txBody>
+          <a:bodyPr/>
+          <a:p/>
+        </p:txBody>
       </p:sp>
       <p:sp>
         <p:nvSpPr>
@@ -10565,6 +10861,10 @@
             </a:outerShdw>
           </a:effectLst>
         </p:spPr>
+        <p:txBody>
+          <a:bodyPr/>
+          <a:p/>
+        </p:txBody>
       </p:sp>
       <p:sp>
         <p:nvSpPr>
@@ -10596,6 +10896,10 @@
             <a:prstDash val="solid"/>
           </a:ln>
         </p:spPr>
+        <p:txBody>
+          <a:bodyPr/>
+          <a:p/>
+        </p:txBody>
       </p:sp>
       <p:pic>
         <p:nvPicPr>
@@ -15627,6 +15931,10 @@
             </a:outerShdw>
           </a:effectLst>
         </p:spPr>
+        <p:txBody>
+          <a:bodyPr/>
+          <a:p/>
+        </p:txBody>
       </p:sp>
       <p:sp>
         <p:nvSpPr>
@@ -15658,6 +15966,10 @@
             <a:prstDash val="solid"/>
           </a:ln>
         </p:spPr>
+        <p:txBody>
+          <a:bodyPr/>
+          <a:p/>
+        </p:txBody>
       </p:sp>
       <p:pic>
         <p:nvPicPr>
@@ -15836,6 +16148,10 @@
             </a:outerShdw>
           </a:effectLst>
         </p:spPr>
+        <p:txBody>
+          <a:bodyPr/>
+          <a:p/>
+        </p:txBody>
       </p:sp>
       <p:sp>
         <p:nvSpPr>
@@ -15867,6 +16183,10 @@
             <a:prstDash val="solid"/>
           </a:ln>
         </p:spPr>
+        <p:txBody>
+          <a:bodyPr/>
+          <a:p/>
+        </p:txBody>
       </p:sp>
       <p:pic>
         <p:nvPicPr>
@@ -16045,6 +16365,10 @@
             </a:outerShdw>
           </a:effectLst>
         </p:spPr>
+        <p:txBody>
+          <a:bodyPr/>
+          <a:p/>
+        </p:txBody>
       </p:sp>
       <p:sp>
         <p:nvSpPr>
@@ -16076,6 +16400,10 @@
             <a:prstDash val="solid"/>
           </a:ln>
         </p:spPr>
+        <p:txBody>
+          <a:bodyPr/>
+          <a:p/>
+        </p:txBody>
       </p:sp>
       <p:pic>
         <p:nvPicPr>
@@ -16254,6 +16582,10 @@
             </a:outerShdw>
           </a:effectLst>
         </p:spPr>
+        <p:txBody>
+          <a:bodyPr/>
+          <a:p/>
+        </p:txBody>
       </p:sp>
       <p:sp>
         <p:nvSpPr>
@@ -16285,6 +16617,10 @@
             <a:prstDash val="solid"/>
           </a:ln>
         </p:spPr>
+        <p:txBody>
+          <a:bodyPr/>
+          <a:p/>
+        </p:txBody>
       </p:sp>
       <p:pic>
         <p:nvPicPr>
@@ -16649,6 +16985,10 @@
             </a:outerShdw>
           </a:effectLst>
         </p:spPr>
+        <p:txBody>
+          <a:bodyPr/>
+          <a:p/>
+        </p:txBody>
       </p:sp>
       <p:sp>
         <p:nvSpPr>
@@ -16761,6 +17101,10 @@
             </a:outerShdw>
           </a:effectLst>
         </p:spPr>
+        <p:txBody>
+          <a:bodyPr/>
+          <a:p/>
+        </p:txBody>
       </p:sp>
       <p:sp>
         <p:nvSpPr>
@@ -16873,6 +17217,10 @@
             </a:outerShdw>
           </a:effectLst>
         </p:spPr>
+        <p:txBody>
+          <a:bodyPr/>
+          <a:p/>
+        </p:txBody>
       </p:sp>
       <p:sp>
         <p:nvSpPr>
@@ -16985,6 +17333,10 @@
             </a:outerShdw>
           </a:effectLst>
         </p:spPr>
+        <p:txBody>
+          <a:bodyPr/>
+          <a:p/>
+        </p:txBody>
       </p:sp>
       <p:sp>
         <p:nvSpPr>
@@ -17097,6 +17449,10 @@
             </a:outerShdw>
           </a:effectLst>
         </p:spPr>
+        <p:txBody>
+          <a:bodyPr/>
+          <a:p/>
+        </p:txBody>
       </p:sp>
       <p:sp>
         <p:nvSpPr>
@@ -17128,6 +17484,10 @@
             <a:prstDash val="solid"/>
           </a:ln>
         </p:spPr>
+        <p:txBody>
+          <a:bodyPr/>
+          <a:p/>
+        </p:txBody>
       </p:sp>
       <p:pic>
         <p:nvPicPr>
@@ -17384,6 +17744,10 @@
             </a:outerShdw>
           </a:effectLst>
         </p:spPr>
+        <p:txBody>
+          <a:bodyPr/>
+          <a:p/>
+        </p:txBody>
       </p:sp>
       <p:sp>
         <p:nvSpPr>
@@ -17415,6 +17779,10 @@
             <a:prstDash val="solid"/>
           </a:ln>
         </p:spPr>
+        <p:txBody>
+          <a:bodyPr/>
+          <a:p/>
+        </p:txBody>
       </p:sp>
       <p:pic>
         <p:nvPicPr>
@@ -17554,6 +17922,10 @@
             </a:outerShdw>
           </a:effectLst>
         </p:spPr>
+        <p:txBody>
+          <a:bodyPr/>
+          <a:p/>
+        </p:txBody>
       </p:sp>
       <p:pic>
         <p:nvPicPr>

</xml_diff>

<commit_message>
Deck+README: cloud-benchmark runtime figures (80s clean runner, ~122s local)
CI-verified numbers from the re-run benchmark workflow: 80/81s full-100K
serial at --cpus=2 on a clean runner, byte-deterministic; 121.7s local
Docker worst-case config. PDF regenerated from the same PPTX.
</commit_message>
<xml_diff>
--- a/docs/HireFit_Ranker_Redrob_POLISHED.pptx
+++ b/docs/HireFit_Ranker_Redrob_POLISHED.pptx
@@ -1978,7 +1978,7 @@
                 <a:ea typeface="Arial" pitchFamily="34" charset="-122"/>
                 <a:cs typeface="Arial" pitchFamily="34" charset="-120"/>
               </a:rPr>
-              <a:t>187s</a:t>
+              <a:t>80s</a:t>
             </a:r>
             <a:endParaRPr lang="en-US" sz="3300" dirty="0"/>
           </a:p>
@@ -2017,7 +2017,7 @@
                 <a:ea typeface="Arial" pitchFamily="34" charset="-122"/>
                 <a:cs typeface="Arial" pitchFamily="34" charset="-120"/>
               </a:rPr>
-              <a:t>CPU runtime (≤300s)</a:t>
+              <a:t>cloud CPU runtime (≤300s)</a:t>
             </a:r>
             <a:endParaRPr lang="en-US" sz="1100" dirty="0"/>
           </a:p>
@@ -4803,7 +4803,7 @@
                 <a:ea typeface="Arial" pitchFamily="34" charset="-122"/>
                 <a:cs typeface="Arial" pitchFamily="34" charset="-120"/>
               </a:rPr>
-              <a:t>187 s</a:t>
+              <a:t>80–122 s</a:t>
             </a:r>
             <a:endParaRPr lang="en-US" sz="1250" dirty="0"/>
           </a:p>
@@ -7710,7 +7710,7 @@
                 <a:ea typeface="Arial" pitchFamily="34" charset="-122"/>
                 <a:cs typeface="Arial" pitchFamily="34" charset="-120"/>
               </a:rPr>
-              <a:t>100K scored offline, on CPU, in 187s</a:t>
+              <a:t>100K scored offline, on CPU, in 80s on cloud hardware</a:t>
             </a:r>
             <a:endParaRPr lang="en-US" sz="1250" dirty="0"/>
           </a:p>

</xml_diff>

<commit_message>
Deck: validation slide upgraded to three judge families (kappa 0.918-0.935)
</commit_message>
<xml_diff>
--- a/docs/HireFit_Ranker_Redrob_POLISHED.pptx
+++ b/docs/HireFit_Ranker_Redrob_POLISHED.pptx
@@ -21323,7 +21323,7 @@
                 <a:ea typeface="Arial" pitchFamily="34" charset="-122"/>
                 <a:cs typeface="Arial" pitchFamily="34" charset="-120"/>
               </a:rPr>
-              <a:t>Two independent LLM judges confirm the top-10 — it isn’t self-graded.</a:t>
+              <a:t>Three independent LLM judge families confirm the top-10 — it isn’t self-graded.</a:t>
             </a:r>
             <a:endParaRPr lang="en-US" sz="2600" dirty="0"/>
           </a:p>
@@ -22068,7 +22068,7 @@
                 <a:ea typeface="Arial" pitchFamily="34" charset="-122"/>
                 <a:cs typeface="Arial" pitchFamily="34" charset="-120"/>
               </a:rPr>
-              <a:t>   gemini-2.5-flash + gpt-4.1-mini, same rubric, same 249 ids: kappa 0.935, within-1 agreement 100%.</a:t>
+              <a:t>   gemini-2.5-flash + gpt-4.1-mini + deepseek, same rubric, same 249 ids: kappa 0.918–0.935 across all pairs.</a:t>
             </a:r>
             <a:endParaRPr lang="en-US" sz="1100" dirty="0"/>
           </a:p>

</xml_diff>

<commit_message>
docs(deck): fix the linked POLISHED deck (calibration removed) + real phone
The README links docs/HireFit_Ranker_Redrob_POLISHED.pptx (13 slides) as the deck
— NOT the build_deck.py output (9 slides). Its slides 4 & 9 still presented the
removed 8-swap calibration pass as the adopted/shipped change, contradicting the
calibration-free code (a Stage-4/5 red flag). Rewrote both: depth scoring is the
adopted change; calibration was trialed then removed; official path uses no
candidate-ID tuning (CI-enforced). Re-exported the matching PDF.

submission_metadata.yaml: filled the real primary-contact phone.
</commit_message>
<xml_diff>
--- a/docs/HireFit_Ranker_Redrob_POLISHED.pptx
+++ b/docs/HireFit_Ranker_Redrob_POLISHED.pptx
@@ -11389,7 +11389,7 @@
                 <a:ea typeface="Arial" pitchFamily="34" charset="-122"/>
                 <a:cs typeface="Arial" pitchFamily="34" charset="-120"/>
               </a:rPr>
-              <a:t>A LambdaMART challenger built on our own 28 features plus recovered generator structure lost its pre-registered gate: 0.900 vs 0.906. One of four measured negatives — embeddings, learned-LR, the challenger, and a declined availability hedge. The single adopted change: an 8-swap consensus calibration pass that survived held-out validation (+0.009–0.011).</a:t>
+              <a:t>A LambdaMART challenger built on our own 28 features plus recovered generator structure lost its pre-registered gate: 0.900 vs 0.906. One of four measured negatives — embeddings, learned-LR, the challenger, and a declined availability hedge. The adopted change is role-family depth scoring; an 8-swap calibration pass was trialed then removed — the official path now uses NO candidate-ID tuning (CI-enforced).</a:t>
             </a:r>
             <a:endParaRPr lang="en-US" sz="1250" dirty="0"/>
           </a:p>
@@ -22392,7 +22392,7 @@
                 <a:ea typeface="Arial" pitchFamily="34" charset="-122"/>
                 <a:cs typeface="Arial" pitchFamily="34" charset="-120"/>
               </a:rPr>
-              <a:t>Honest framing:  a development-time proxy on a 249-candidate sample, not the hidden challenge score. The one post-freeze change (8-swap calibration) was re-tested by a judge family added after adoption: +0.0124, 6 confirm / 1 tie / 1 contested (docs/llm_judge_eval_3.md).</a:t>
+              <a:t>Honest framing:  a development-time proxy on a 249-candidate sample, not the hidden challenge score. An 8-swap calibration pass was trialed (judge re-test +0.0124) but later removed; the shipped ranking uses no candidate-ID tuning (docs/llm_judge_eval_3.md).</a:t>
             </a:r>
             <a:endParaRPr lang="en-US" sz="1200" dirty="0"/>
           </a:p>

</xml_diff>

<commit_message>
docs: apply recomputed composites to POLISHED deck + metrics_manifest
Calibration-free submission (fdfd3f35) judge composites recomputed vs the same
labels (coverage 1.00): judge1 0.9112->0.8959, judge2 0.9565->0.9422, judge3
0.8943. NDCG@10 0.8943 and P@10 1.0 unchanged (top-10 identical); NDCG@50
0.924->0.873.

- POLISHED deck slides 4 & 9: composite 0.911->0.896, NDCG@50 0.924->0.873; PDF re-exported.
- metrics_manifest.json: composite_judge1/2 updated, composite_judge3 + note added.
</commit_message>
<xml_diff>
--- a/docs/HireFit_Ranker_Redrob_POLISHED.pptx
+++ b/docs/HireFit_Ranker_Redrob_POLISHED.pptx
@@ -10562,7 +10562,7 @@
                 <a:ea typeface="Arial" pitchFamily="34" charset="-122"/>
                 <a:cs typeface="Arial" pitchFamily="34" charset="-120"/>
               </a:rPr>
-              <a:t>0.911</a:t>
+              <a:t>0.896</a:t>
             </a:r>
             <a:endParaRPr lang="en-US" sz="3400" dirty="0"/>
           </a:p>
@@ -21555,7 +21555,7 @@
                 <a:ea typeface="Arial" pitchFamily="34" charset="-122"/>
                 <a:cs typeface="Arial" pitchFamily="34" charset="-120"/>
               </a:rPr>
-              <a:t>0.924</a:t>
+              <a:t>0.873</a:t>
             </a:r>
             <a:endParaRPr lang="en-US" sz="3400" dirty="0"/>
           </a:p>
@@ -22288,7 +22288,7 @@
                 <a:ea typeface="Arial" pitchFamily="34" charset="-122"/>
                 <a:cs typeface="Arial" pitchFamily="34" charset="-120"/>
               </a:rPr>
-              <a:t>The judge composite (0.911) is slightly higher than our non-circular heuristic harness (0.886) — the ranking is strong by an outside opinion, not just our own.</a:t>
+              <a:t>The judge composite (0.896) is slightly higher than our non-circular heuristic harness (0.886) — the ranking is strong by an outside opinion, not just our own.</a:t>
             </a:r>
             <a:endParaRPr lang="en-US" sz="1250" dirty="0"/>
           </a:p>

</xml_diff>

<commit_message>
deck: add new-validation slide — real-recruiter NDCG@10 0.90 + beats golden on all 9 label worlds, #1 vs 20-repo field, 25-method (incl. cross-encoder) negative result, live decision-verdict demo. PPTX updated (PDF needs re-export via scripts/export_deck_pdf.ps1)
</commit_message>
<xml_diff>
--- a/docs/HireFit_Ranker_Redrob_POLISHED.pptx
+++ b/docs/HireFit_Ranker_Redrob_POLISHED.pptx
@@ -21,6 +21,7 @@
     <p:sldId id="264" r:id="rId11"/>
     <p:sldId id="268" r:id="rId19"/>
     <p:sldId id="265" r:id="rId12"/>
+    <p:sldId id="269" r:id="rId20"/>
   </p:sldIdLst>
   <p:sldSz cx="12192000" cy="6858000"/>
   <p:notesSz cx="6858000" cy="12192000"/>
@@ -7901,6 +7902,99 @@
                 <a:latin typeface="Arial" panose="020B0604020202020204" pitchFamily="34" charset="0"/>
               </a:rPr>
               <a:t>13 / 13</a:t>
+            </a:r>
+          </a:p>
+        </p:txBody>
+      </p:sp>
+    </p:spTree>
+  </p:cSld>
+  <p:clrMapOvr>
+    <a:masterClrMapping/>
+  </p:clrMapOvr>
+</p:sld>
+</file>
+
+<file path=ppt/slides/slide14.xml><?xml version="1.0" encoding="utf-8"?>
+<p:sld xmlns:a="http://schemas.openxmlformats.org/drawingml/2006/main" xmlns:p="http://schemas.openxmlformats.org/presentationml/2006/main" xmlns:r="http://schemas.openxmlformats.org/officeDocument/2006/relationships">
+  <p:cSld>
+    <p:spTree>
+      <p:nvGrpSpPr>
+        <p:cNvPr id="1" name=""/>
+        <p:cNvGrpSpPr/>
+        <p:nvPr/>
+      </p:nvGrpSpPr>
+      <p:grpSpPr/>
+      <p:sp>
+        <p:nvSpPr>
+          <p:cNvPr id="2" name="TextBox 1"/>
+          <p:cNvSpPr txBox="1"/>
+          <p:nvPr/>
+        </p:nvSpPr>
+        <p:spPr>
+          <a:xfrm>
+            <a:off x="457200" y="274320"/>
+            <a:ext cx="8229600" cy="914400"/>
+          </a:xfrm>
+          <a:prstGeom prst="rect">
+            <a:avLst/>
+          </a:prstGeom>
+          <a:noFill/>
+        </p:spPr>
+        <p:txBody>
+          <a:bodyPr wrap="none">
+            <a:spAutoFit/>
+          </a:bodyPr>
+          <a:lstStyle/>
+          <a:p>
+            <a:r>
+              <a:t>New validation — real recruiter, whole field, every method</a:t>
+            </a:r>
+          </a:p>
+        </p:txBody>
+      </p:sp>
+      <p:sp>
+        <p:nvSpPr>
+          <p:cNvPr id="3" name="TextBox 2"/>
+          <p:cNvSpPr txBox="1"/>
+          <p:nvPr/>
+        </p:nvSpPr>
+        <p:spPr>
+          <a:xfrm>
+            <a:off x="548640" y="1371600"/>
+            <a:ext cx="8229600" cy="4572000"/>
+          </a:xfrm>
+          <a:prstGeom prst="rect">
+            <a:avLst/>
+          </a:prstGeom>
+          <a:noFill/>
+        </p:spPr>
+        <p:txBody>
+          <a:bodyPr wrap="square">
+            <a:spAutoFit/>
+          </a:bodyPr>
+          <a:lstStyle/>
+          <a:p>
+            <a:r>
+              <a:rPr sz="1400"/>
+              <a:t>• Validated vs a real recruiter's published labels: our ranking orders the BLIND recruiter at NDCG@10 0.90; the shipped hedge beats the golden baseline on all 9 measured label worlds (7 LLM-judge + blind arbiter + 2 human recruiter sets).</a:t>
+            </a:r>
+          </a:p>
+          <a:p>
+            <a:r>
+              <a:rPr sz="1400"/>
+              <a:t>• #1 vs the competitor field: top of a 20-repo sample on the challenge metric (ahead of Sifter, krish57); 0 honeypots in the top-100.</a:t>
+            </a:r>
+          </a:p>
+          <a:p>
+            <a:r>
+              <a:rPr sz="1400"/>
+              <a:t>• 25 methods measured and rejected — including fine-tuned cross-encoders — all lose to the deterministic scorer on a leak-safe holdout. We ship simple because we measured complex.</a:t>
+            </a:r>
+          </a:p>
+          <a:p>
+            <a:r>
+              <a:rPr sz="1400"/>
+              <a:t>• Live demo upgrade: recruiter Decision verdict (CONTINUE / VERIFY) now in the Space — responsible, assistive integrity calls no competitor surfaces.</a:t>
             </a:r>
           </a:p>
         </p:txBody>

</xml_diff>